<commit_message>
chore(devops): PPTX actualizado con URL Railway + QR embebido
- dailys/Daily_S2_Sprint1_HELIOS.pptx: slide 2 ahora muestra QR (574x574px,
  color HELIOS teal) + URL del deploy live: helios-web-production.up.railway.app
- dailys/qr_helios_demo.png: QR generado con qrcode lib, alta correccion
  para que se escanee bien desde proyector/pantalla
- scripts/generar_pptx.py: layout 2 columnas reducidas + bloque QR a la
  derecha + stats actualizados (2700 horarios reales del seed)

Listo para entrega del jueves: companeros pueden escanear el QR desde el
salon y probar HELIOS desde su movil/laptop.
</commit_message>
<xml_diff>
--- a/dailys/Daily_S2_Sprint1_HELIOS.pptx
+++ b/dailys/Daily_S2_Sprint1_HELIOS.pptx
@@ -3687,7 +3687,7 @@
         <p:spPr>
           <a:xfrm>
             <a:off x="457200" y="2103120"/>
-            <a:ext cx="5486400" cy="54864"/>
+            <a:ext cx="4297680" cy="54864"/>
           </a:xfrm>
           <a:prstGeom prst="rect">
             <a:avLst/>
@@ -3731,7 +3731,7 @@
         <p:spPr>
           <a:xfrm>
             <a:off x="457200" y="2240280"/>
-            <a:ext cx="5486400" cy="365760"/>
+            <a:ext cx="4297680" cy="365760"/>
           </a:xfrm>
           <a:prstGeom prst="rect">
             <a:avLst/>
@@ -3766,7 +3766,7 @@
         <p:spPr>
           <a:xfrm>
             <a:off x="457200" y="2651760"/>
-            <a:ext cx="5486400" cy="2286000"/>
+            <a:ext cx="4297680" cy="2286000"/>
           </a:xfrm>
           <a:prstGeom prst="rect">
             <a:avLst/>
@@ -3913,8 +3913,8 @@
         </p:nvSpPr>
         <p:spPr>
           <a:xfrm>
-            <a:off x="6400800" y="2103120"/>
-            <a:ext cx="5486400" cy="54864"/>
+            <a:off x="4846320" y="2103120"/>
+            <a:ext cx="4297680" cy="54864"/>
           </a:xfrm>
           <a:prstGeom prst="rect">
             <a:avLst/>
@@ -3957,8 +3957,8 @@
         </p:nvSpPr>
         <p:spPr>
           <a:xfrm>
-            <a:off x="6400800" y="2240280"/>
-            <a:ext cx="5486400" cy="365760"/>
+            <a:off x="4846320" y="2240280"/>
+            <a:ext cx="4297680" cy="365760"/>
           </a:xfrm>
           <a:prstGeom prst="rect">
             <a:avLst/>
@@ -3992,8 +3992,8 @@
         </p:nvSpPr>
         <p:spPr>
           <a:xfrm>
-            <a:off x="6400800" y="2651760"/>
-            <a:ext cx="5486400" cy="2286000"/>
+            <a:off x="4846320" y="2651760"/>
+            <a:ext cx="4297680" cy="2286000"/>
           </a:xfrm>
           <a:prstGeom prst="rect">
             <a:avLst/>
@@ -4157,16 +4157,145 @@
           </a:p>
         </p:txBody>
       </p:sp>
-      <p:sp>
-        <p:nvSpPr>
-          <p:cNvPr id="13" name="Rectangle 12"/>
+      <p:pic>
+        <p:nvPicPr>
+          <p:cNvPr id="13" name="Picture 12" descr="qr_helios_demo.png"/>
+          <p:cNvPicPr>
+            <a:picLocks noChangeAspect="1"/>
+          </p:cNvPicPr>
+          <p:nvPr/>
+        </p:nvPicPr>
+        <p:blipFill>
+          <a:blip r:embed="rId2"/>
+          <a:stretch>
+            <a:fillRect/>
+          </a:stretch>
+        </p:blipFill>
+        <p:spPr>
+          <a:xfrm>
+            <a:off x="9601200" y="2103120"/>
+            <a:ext cx="2103120" cy="2103120"/>
+          </a:xfrm>
+          <a:prstGeom prst="rect">
+            <a:avLst/>
+          </a:prstGeom>
+        </p:spPr>
+      </p:pic>
+      <p:sp>
+        <p:nvSpPr>
+          <p:cNvPr id="14" name="TextBox 13"/>
+          <p:cNvSpPr txBox="1"/>
+          <p:nvPr/>
+        </p:nvSpPr>
+        <p:spPr>
+          <a:xfrm>
+            <a:off x="9601200" y="4251960"/>
+            <a:ext cx="2103120" cy="274320"/>
+          </a:xfrm>
+          <a:prstGeom prst="rect">
+            <a:avLst/>
+          </a:prstGeom>
+          <a:noFill/>
+        </p:spPr>
+        <p:txBody>
+          <a:bodyPr wrap="square" lIns="0" rIns="0" tIns="0" bIns="0">
+            <a:spAutoFit/>
+          </a:bodyPr>
+          <a:lstStyle/>
+          <a:p>
+            <a:pPr algn="ctr"/>
+            <a:r>
+              <a:rPr sz="1000" b="1">
+                <a:solidFill>
+                  <a:srgbClr val="0A8478"/>
+                </a:solidFill>
+                <a:latin typeface="Calibri"/>
+              </a:rPr>
+              <a:t>Escanea el QR</a:t>
+            </a:r>
+          </a:p>
+        </p:txBody>
+      </p:sp>
+      <p:sp>
+        <p:nvSpPr>
+          <p:cNvPr id="15" name="TextBox 14"/>
+          <p:cNvSpPr txBox="1"/>
+          <p:nvPr/>
+        </p:nvSpPr>
+        <p:spPr>
+          <a:xfrm>
+            <a:off x="9601200" y="4526280"/>
+            <a:ext cx="2103120" cy="274320"/>
+          </a:xfrm>
+          <a:prstGeom prst="rect">
+            <a:avLst/>
+          </a:prstGeom>
+          <a:noFill/>
+        </p:spPr>
+        <p:txBody>
+          <a:bodyPr wrap="square" lIns="0" rIns="0" tIns="0" bIns="0">
+            <a:spAutoFit/>
+          </a:bodyPr>
+          <a:lstStyle/>
+          <a:p>
+            <a:pPr algn="ctr"/>
+            <a:r>
+              <a:rPr sz="800" b="0">
+                <a:solidFill>
+                  <a:srgbClr val="4A6B7A"/>
+                </a:solidFill>
+                <a:latin typeface="Calibri"/>
+              </a:rPr>
+              <a:t>helios-web-production</a:t>
+            </a:r>
+          </a:p>
+        </p:txBody>
+      </p:sp>
+      <p:sp>
+        <p:nvSpPr>
+          <p:cNvPr id="16" name="TextBox 15"/>
+          <p:cNvSpPr txBox="1"/>
+          <p:nvPr/>
+        </p:nvSpPr>
+        <p:spPr>
+          <a:xfrm>
+            <a:off x="9601200" y="4736592"/>
+            <a:ext cx="2103120" cy="274320"/>
+          </a:xfrm>
+          <a:prstGeom prst="rect">
+            <a:avLst/>
+          </a:prstGeom>
+          <a:noFill/>
+        </p:spPr>
+        <p:txBody>
+          <a:bodyPr wrap="square" lIns="0" rIns="0" tIns="0" bIns="0">
+            <a:spAutoFit/>
+          </a:bodyPr>
+          <a:lstStyle/>
+          <a:p>
+            <a:pPr algn="ctr"/>
+            <a:r>
+              <a:rPr sz="800" b="0">
+                <a:solidFill>
+                  <a:srgbClr val="4A6B7A"/>
+                </a:solidFill>
+                <a:latin typeface="Calibri"/>
+              </a:rPr>
+              <a:t>.up.railway.app</a:t>
+            </a:r>
+          </a:p>
+        </p:txBody>
+      </p:sp>
+      <p:sp>
+        <p:nvSpPr>
+          <p:cNvPr id="17" name="Rectangle 16"/>
           <p:cNvSpPr/>
           <p:nvPr/>
         </p:nvSpPr>
         <p:spPr>
           <a:xfrm>
-            <a:off x="457200" y="5120640"/>
-            <a:ext cx="11247120" cy="1097280"/>
+            <a:off x="457200" y="5212080"/>
+            <a:ext cx="11247120" cy="1005840"/>
           </a:xfrm>
           <a:prstGeom prst="rect">
             <a:avLst/>
@@ -4203,14 +4332,14 @@
       </p:sp>
       <p:sp>
         <p:nvSpPr>
-          <p:cNvPr id="14" name="Rectangle 13"/>
+          <p:cNvPr id="18" name="Rectangle 17"/>
           <p:cNvSpPr/>
           <p:nvPr/>
         </p:nvSpPr>
         <p:spPr>
           <a:xfrm>
-            <a:off x="457200" y="5120640"/>
-            <a:ext cx="91440" cy="1097280"/>
+            <a:off x="457200" y="5212080"/>
+            <a:ext cx="91440" cy="1005840"/>
           </a:xfrm>
           <a:prstGeom prst="rect">
             <a:avLst/>
@@ -4247,13 +4376,13 @@
       </p:sp>
       <p:sp>
         <p:nvSpPr>
-          <p:cNvPr id="15" name="TextBox 14"/>
-          <p:cNvSpPr txBox="1"/>
-          <p:nvPr/>
-        </p:nvSpPr>
-        <p:spPr>
-          <a:xfrm>
-            <a:off x="731520" y="5285232"/>
+          <p:cNvPr id="19" name="TextBox 18"/>
+          <p:cNvSpPr txBox="1"/>
+          <p:nvPr/>
+        </p:nvSpPr>
+        <p:spPr>
+          <a:xfrm>
+            <a:off x="731520" y="5376672"/>
             <a:ext cx="2194560" cy="457200"/>
           </a:xfrm>
           <a:prstGeom prst="rect">
@@ -4275,20 +4404,20 @@
                 </a:solidFill>
                 <a:latin typeface="Calibri"/>
               </a:rPr>
-              <a:t>28</a:t>
-            </a:r>
-          </a:p>
-        </p:txBody>
-      </p:sp>
-      <p:sp>
-        <p:nvSpPr>
-          <p:cNvPr id="16" name="TextBox 15"/>
-          <p:cNvSpPr txBox="1"/>
-          <p:nvPr/>
-        </p:nvSpPr>
-        <p:spPr>
-          <a:xfrm>
-            <a:off x="731520" y="5779008"/>
+              <a:t>32</a:t>
+            </a:r>
+          </a:p>
+        </p:txBody>
+      </p:sp>
+      <p:sp>
+        <p:nvSpPr>
+          <p:cNvPr id="20" name="TextBox 19"/>
+          <p:cNvSpPr txBox="1"/>
+          <p:nvPr/>
+        </p:nvSpPr>
+        <p:spPr>
+          <a:xfrm>
+            <a:off x="731520" y="5852160"/>
             <a:ext cx="2194560" cy="365760"/>
           </a:xfrm>
           <a:prstGeom prst="rect">
@@ -4310,20 +4439,20 @@
                 </a:solidFill>
                 <a:latin typeface="Calibri"/>
               </a:rPr>
-              <a:t>archivos TS/TSX nuevos</a:t>
-            </a:r>
-          </a:p>
-        </p:txBody>
-      </p:sp>
-      <p:sp>
-        <p:nvSpPr>
-          <p:cNvPr id="17" name="TextBox 16"/>
-          <p:cNvSpPr txBox="1"/>
-          <p:nvPr/>
-        </p:nvSpPr>
-        <p:spPr>
-          <a:xfrm>
-            <a:off x="2926080" y="5285232"/>
+              <a:t>archivos TS/TSX</a:t>
+            </a:r>
+          </a:p>
+        </p:txBody>
+      </p:sp>
+      <p:sp>
+        <p:nvSpPr>
+          <p:cNvPr id="21" name="TextBox 20"/>
+          <p:cNvSpPr txBox="1"/>
+          <p:nvPr/>
+        </p:nvSpPr>
+        <p:spPr>
+          <a:xfrm>
+            <a:off x="2926080" y="5376672"/>
             <a:ext cx="2194560" cy="457200"/>
           </a:xfrm>
           <a:prstGeom prst="rect">
@@ -4352,13 +4481,13 @@
       </p:sp>
       <p:sp>
         <p:nvSpPr>
-          <p:cNvPr id="18" name="TextBox 17"/>
-          <p:cNvSpPr txBox="1"/>
-          <p:nvPr/>
-        </p:nvSpPr>
-        <p:spPr>
-          <a:xfrm>
-            <a:off x="2926080" y="5779008"/>
+          <p:cNvPr id="22" name="TextBox 21"/>
+          <p:cNvSpPr txBox="1"/>
+          <p:nvPr/>
+        </p:nvSpPr>
+        <p:spPr>
+          <a:xfrm>
+            <a:off x="2926080" y="5852160"/>
             <a:ext cx="2194560" cy="365760"/>
           </a:xfrm>
           <a:prstGeom prst="rect">
@@ -4380,20 +4509,20 @@
                 </a:solidFill>
                 <a:latin typeface="Calibri"/>
               </a:rPr>
-              <a:t>tests automatizados</a:t>
-            </a:r>
-          </a:p>
-        </p:txBody>
-      </p:sp>
-      <p:sp>
-        <p:nvSpPr>
-          <p:cNvPr id="19" name="TextBox 18"/>
-          <p:cNvSpPr txBox="1"/>
-          <p:nvPr/>
-        </p:nvSpPr>
-        <p:spPr>
-          <a:xfrm>
-            <a:off x="5120640" y="5285232"/>
+              <a:t>tests pasando</a:t>
+            </a:r>
+          </a:p>
+        </p:txBody>
+      </p:sp>
+      <p:sp>
+        <p:nvSpPr>
+          <p:cNvPr id="23" name="TextBox 22"/>
+          <p:cNvSpPr txBox="1"/>
+          <p:nvPr/>
+        </p:nvSpPr>
+        <p:spPr>
+          <a:xfrm>
+            <a:off x="5120640" y="5376672"/>
             <a:ext cx="2194560" cy="457200"/>
           </a:xfrm>
           <a:prstGeom prst="rect">
@@ -4422,13 +4551,13 @@
       </p:sp>
       <p:sp>
         <p:nvSpPr>
-          <p:cNvPr id="20" name="TextBox 19"/>
-          <p:cNvSpPr txBox="1"/>
-          <p:nvPr/>
-        </p:nvSpPr>
-        <p:spPr>
-          <a:xfrm>
-            <a:off x="5120640" y="5779008"/>
+          <p:cNvPr id="24" name="TextBox 23"/>
+          <p:cNvSpPr txBox="1"/>
+          <p:nvPr/>
+        </p:nvSpPr>
+        <p:spPr>
+          <a:xfrm>
+            <a:off x="5120640" y="5852160"/>
             <a:ext cx="2194560" cy="365760"/>
           </a:xfrm>
           <a:prstGeom prst="rect">
@@ -4450,20 +4579,20 @@
                 </a:solidFill>
                 <a:latin typeface="Calibri"/>
               </a:rPr>
-              <a:t>cobertura statements</a:t>
-            </a:r>
-          </a:p>
-        </p:txBody>
-      </p:sp>
-      <p:sp>
-        <p:nvSpPr>
-          <p:cNvPr id="21" name="TextBox 20"/>
-          <p:cNvSpPr txBox="1"/>
-          <p:nvPr/>
-        </p:nvSpPr>
-        <p:spPr>
-          <a:xfrm>
-            <a:off x="7315200" y="5285232"/>
+              <a:t>cobertura stmts</a:t>
+            </a:r>
+          </a:p>
+        </p:txBody>
+      </p:sp>
+      <p:sp>
+        <p:nvSpPr>
+          <p:cNvPr id="25" name="TextBox 24"/>
+          <p:cNvSpPr txBox="1"/>
+          <p:nvPr/>
+        </p:nvSpPr>
+        <p:spPr>
+          <a:xfrm>
+            <a:off x="7315200" y="5376672"/>
             <a:ext cx="2194560" cy="457200"/>
           </a:xfrm>
           <a:prstGeom prst="rect">
@@ -4485,20 +4614,20 @@
                 </a:solidFill>
                 <a:latin typeface="Calibri"/>
               </a:rPr>
-              <a:t>100%</a:t>
-            </a:r>
-          </a:p>
-        </p:txBody>
-      </p:sp>
-      <p:sp>
-        <p:nvSpPr>
-          <p:cNvPr id="22" name="TextBox 21"/>
-          <p:cNvSpPr txBox="1"/>
-          <p:nvPr/>
-        </p:nvSpPr>
-        <p:spPr>
-          <a:xfrm>
-            <a:off x="7315200" y="5779008"/>
+              <a:t>2,700</a:t>
+            </a:r>
+          </a:p>
+        </p:txBody>
+      </p:sp>
+      <p:sp>
+        <p:nvSpPr>
+          <p:cNvPr id="26" name="TextBox 25"/>
+          <p:cNvSpPr txBox="1"/>
+          <p:nvPr/>
+        </p:nvSpPr>
+        <p:spPr>
+          <a:xfrm>
+            <a:off x="7315200" y="5852160"/>
             <a:ext cx="2194560" cy="365760"/>
           </a:xfrm>
           <a:prstGeom prst="rect">
@@ -4520,20 +4649,20 @@
                 </a:solidFill>
                 <a:latin typeface="Calibri"/>
               </a:rPr>
-              <a:t>US-01..05 implementadas</a:t>
-            </a:r>
-          </a:p>
-        </p:txBody>
-      </p:sp>
-      <p:sp>
-        <p:nvSpPr>
-          <p:cNvPr id="23" name="TextBox 22"/>
-          <p:cNvSpPr txBox="1"/>
-          <p:nvPr/>
-        </p:nvSpPr>
-        <p:spPr>
-          <a:xfrm>
-            <a:off x="9509760" y="5285232"/>
+              <a:t>horarios en BD</a:t>
+            </a:r>
+          </a:p>
+        </p:txBody>
+      </p:sp>
+      <p:sp>
+        <p:nvSpPr>
+          <p:cNvPr id="27" name="TextBox 26"/>
+          <p:cNvSpPr txBox="1"/>
+          <p:nvPr/>
+        </p:nvSpPr>
+        <p:spPr>
+          <a:xfrm>
+            <a:off x="9509760" y="5376672"/>
             <a:ext cx="2194560" cy="457200"/>
           </a:xfrm>
           <a:prstGeom prst="rect">
@@ -4555,20 +4684,20 @@
                 </a:solidFill>
                 <a:latin typeface="Calibri"/>
               </a:rPr>
-              <a:t>0</a:t>
-            </a:r>
-          </a:p>
-        </p:txBody>
-      </p:sp>
-      <p:sp>
-        <p:nvSpPr>
-          <p:cNvPr id="24" name="TextBox 23"/>
-          <p:cNvSpPr txBox="1"/>
-          <p:nvPr/>
-        </p:nvSpPr>
-        <p:spPr>
-          <a:xfrm>
-            <a:off x="9509760" y="5779008"/>
+              <a:t>5/5</a:t>
+            </a:r>
+          </a:p>
+        </p:txBody>
+      </p:sp>
+      <p:sp>
+        <p:nvSpPr>
+          <p:cNvPr id="28" name="TextBox 27"/>
+          <p:cNvSpPr txBox="1"/>
+          <p:nvPr/>
+        </p:nvSpPr>
+        <p:spPr>
+          <a:xfrm>
+            <a:off x="9509760" y="5852160"/>
             <a:ext cx="2194560" cy="365760"/>
           </a:xfrm>
           <a:prstGeom prst="rect">
@@ -4590,14 +4719,14 @@
                 </a:solidFill>
                 <a:latin typeface="Calibri"/>
               </a:rPr>
-              <a:t>vulnerabilidades críticas</a:t>
-            </a:r>
-          </a:p>
-        </p:txBody>
-      </p:sp>
-      <p:sp>
-        <p:nvSpPr>
-          <p:cNvPr id="25" name="TextBox 24"/>
+              <a:t>US implementadas</a:t>
+            </a:r>
+          </a:p>
+        </p:txBody>
+      </p:sp>
+      <p:sp>
+        <p:nvSpPr>
+          <p:cNvPr id="29" name="TextBox 28"/>
           <p:cNvSpPr txBox="1"/>
           <p:nvPr/>
         </p:nvSpPr>

</xml_diff>

<commit_message>
docs(pptx): slide 5 nueva con screenshot del backlog Jira HELL
Cambios en el PPTX:
- 6 slides totales (antes 5)
- Tono ajustado: pill "ETAPA: SPRINT 1 - MVP ACADEMICO" en slide portada
- Texto slide 2: "MVP academico funcional para validacion" (antes "producto desplegado")
- NUEVA slide 5: "Evidencias de herramientas - Backlog Jira HELL"
  con screenshot real del tab List de Jira mostrando las 22 issues
  (15 creadas via API + 7 anteriores del proyecto)
- Slide 6 (antes 5): Metricas Unidad II con interpretacion Locust
- Stats actualizados: 53 SP, 15 issues, 5400 horarios

Cumple los 5 puntos de la rubrica de la dinamica:
1. Avance del desarrollo - codigo + metricas
2. Evidencias Unidad II - ISTQB/TMMi/TQM citados
3. Registro de metricas - 13 filas en tabla
4. Evidencias de herramientas - screenshot Jira embebido
5. Backlog/Kanban actualizado - tab List visible con 22 issues
</commit_message>
<xml_diff>
--- a/dailys/Daily_S2_Sprint1_HELIOS.pptx
+++ b/dailys/Daily_S2_Sprint1_HELIOS.pptx
@@ -10,6 +10,7 @@
     <p:sldId id="258" r:id="rId9"/>
     <p:sldId id="259" r:id="rId10"/>
     <p:sldId id="260" r:id="rId11"/>
+    <p:sldId id="261" r:id="rId12"/>
   </p:sldIdLst>
   <p:sldSz cx="12191695" cy="6858000" type="screen4x3"/>
   <p:notesSz cx="6858000" cy="9144000"/>
@@ -3330,13 +3331,67 @@
       </p:sp>
       <p:sp>
         <p:nvSpPr>
-          <p:cNvPr id="8" name="Rectangle 7"/>
+          <p:cNvPr id="8" name="Rounded Rectangle 7"/>
           <p:cNvSpPr/>
           <p:nvPr/>
         </p:nvSpPr>
         <p:spPr>
           <a:xfrm>
-            <a:off x="640080" y="4023360"/>
+            <a:off x="640080" y="3840480"/>
+            <a:ext cx="3200400" cy="365760"/>
+          </a:xfrm>
+          <a:prstGeom prst="roundRect">
+            <a:avLst>
+              <a:gd name="adj" fmla="val 50000"/>
+            </a:avLst>
+          </a:prstGeom>
+          <a:solidFill>
+            <a:srgbClr val="CA8A04"/>
+          </a:solidFill>
+          <a:ln>
+            <a:noFill/>
+          </a:ln>
+        </p:spPr>
+        <p:style>
+          <a:lnRef idx="1">
+            <a:schemeClr val="accent1"/>
+          </a:lnRef>
+          <a:fillRef idx="3">
+            <a:schemeClr val="accent1"/>
+          </a:fillRef>
+          <a:effectRef idx="2">
+            <a:schemeClr val="accent1"/>
+          </a:effectRef>
+          <a:fontRef idx="minor">
+            <a:schemeClr val="lt1"/>
+          </a:fontRef>
+        </p:style>
+        <p:txBody>
+          <a:bodyPr rtlCol="0" anchor="ctr" lIns="0" rIns="0" tIns="0" bIns="0"/>
+          <a:lstStyle/>
+          <a:p>
+            <a:pPr algn="ctr"/>
+            <a:r>
+              <a:rPr sz="900" b="1">
+                <a:solidFill>
+                  <a:srgbClr val="FFFFFF"/>
+                </a:solidFill>
+                <a:latin typeface="Calibri"/>
+              </a:rPr>
+              <a:t>ETAPA: SPRINT 1 - MVP ACADEMICO</a:t>
+            </a:r>
+          </a:p>
+        </p:txBody>
+      </p:sp>
+      <p:sp>
+        <p:nvSpPr>
+          <p:cNvPr id="9" name="Rectangle 8"/>
+          <p:cNvSpPr/>
+          <p:nvPr/>
+        </p:nvSpPr>
+        <p:spPr>
+          <a:xfrm>
+            <a:off x="640080" y="4389120"/>
             <a:ext cx="365760" cy="45720"/>
           </a:xfrm>
           <a:prstGeom prst="rect">
@@ -3374,13 +3429,13 @@
       </p:sp>
       <p:sp>
         <p:nvSpPr>
-          <p:cNvPr id="9" name="TextBox 8"/>
-          <p:cNvSpPr txBox="1"/>
-          <p:nvPr/>
-        </p:nvSpPr>
-        <p:spPr>
-          <a:xfrm>
-            <a:off x="640080" y="4206240"/>
+          <p:cNvPr id="10" name="TextBox 9"/>
+          <p:cNvSpPr txBox="1"/>
+          <p:nvPr/>
+        </p:nvSpPr>
+        <p:spPr>
+          <a:xfrm>
+            <a:off x="640080" y="4572000"/>
             <a:ext cx="4572000" cy="365760"/>
           </a:xfrm>
           <a:prstGeom prst="rect">
@@ -3409,13 +3464,13 @@
       </p:sp>
       <p:sp>
         <p:nvSpPr>
-          <p:cNvPr id="10" name="TextBox 9"/>
-          <p:cNvSpPr txBox="1"/>
-          <p:nvPr/>
-        </p:nvSpPr>
-        <p:spPr>
-          <a:xfrm>
-            <a:off x="640080" y="4572000"/>
+          <p:cNvPr id="11" name="TextBox 10"/>
+          <p:cNvSpPr txBox="1"/>
+          <p:nvPr/>
+        </p:nvSpPr>
+        <p:spPr>
+          <a:xfrm>
+            <a:off x="640080" y="4937760"/>
             <a:ext cx="10515600" cy="457200"/>
           </a:xfrm>
           <a:prstGeom prst="rect">
@@ -3444,7 +3499,7 @@
       </p:sp>
       <p:sp>
         <p:nvSpPr>
-          <p:cNvPr id="11" name="TextBox 10"/>
+          <p:cNvPr id="12" name="TextBox 11"/>
           <p:cNvSpPr txBox="1"/>
           <p:nvPr/>
         </p:nvSpPr>
@@ -3603,7 +3658,7 @@
                 </a:solidFill>
                 <a:latin typeface="Calibri"/>
               </a:rPr>
-              <a:t>2 / 5</a:t>
+              <a:t>2 / 6</a:t>
             </a:r>
           </a:p>
         </p:txBody>
@@ -3673,7 +3728,7 @@
                 </a:solidFill>
                 <a:latin typeface="Calibri"/>
               </a:rPr>
-              <a:t>Pasamos de Sprint 0 (documentación) a producto funcional desplegado</a:t>
+              <a:t>Pasamos de Sprint 0 (documentación) a MVP académico funcional para validación con compañeros</a:t>
             </a:r>
           </a:p>
         </p:txBody>
@@ -3800,7 +3855,7 @@
                 </a:solidFill>
                 <a:latin typeface="Calibri"/>
               </a:rPr>
-              <a:t>Schema PostgreSQL ejecutado en Supabase (7 tablas + RLS + RPC atómica)</a:t>
+              <a:t>Schema PostgreSQL ejecutado: 7 tablas + RLS + RPC atómica</a:t>
             </a:r>
           </a:p>
           <a:p>
@@ -4885,7 +4940,7 @@
                 </a:solidFill>
                 <a:latin typeface="Calibri"/>
               </a:rPr>
-              <a:t>3 / 5</a:t>
+              <a:t>3 / 6</a:t>
             </a:r>
           </a:p>
         </p:txBody>
@@ -6637,7 +6692,7 @@
                 </a:solidFill>
                 <a:latin typeface="Calibri"/>
               </a:rPr>
-              <a:t>4 / 5</a:t>
+              <a:t>4 / 6</a:t>
             </a:r>
           </a:p>
         </p:txBody>
@@ -8038,7 +8093,7 @@
                 </a:solidFill>
                 <a:latin typeface="Calibri"/>
               </a:rPr>
-              <a:t>APLICACIÓN DE LA UNIDAD II — ISTQB · TMMI · TQM</a:t>
+              <a:t>EVIDENCIAS DE HERRAMIENTAS — BACKLOG JIRA HELL</a:t>
             </a:r>
           </a:p>
         </p:txBody>
@@ -8108,7 +8163,392 @@
                 </a:solidFill>
                 <a:latin typeface="Calibri"/>
               </a:rPr>
-              <a:t>5 / 5</a:t>
+              <a:t>5 / 6</a:t>
+            </a:r>
+          </a:p>
+        </p:txBody>
+      </p:sp>
+      <p:sp>
+        <p:nvSpPr>
+          <p:cNvPr id="5" name="TextBox 4"/>
+          <p:cNvSpPr txBox="1"/>
+          <p:nvPr/>
+        </p:nvSpPr>
+        <p:spPr>
+          <a:xfrm>
+            <a:off x="457200" y="731520"/>
+            <a:ext cx="10972800" cy="640080"/>
+          </a:xfrm>
+          <a:prstGeom prst="rect">
+            <a:avLst/>
+          </a:prstGeom>
+          <a:noFill/>
+        </p:spPr>
+        <p:txBody>
+          <a:bodyPr wrap="square" lIns="0" rIns="0" tIns="0" bIns="0">
+            <a:spAutoFit/>
+          </a:bodyPr>
+          <a:lstStyle/>
+          <a:p>
+            <a:pPr algn="l"/>
+            <a:r>
+              <a:rPr sz="2800" b="1">
+                <a:solidFill>
+                  <a:srgbClr val="0A4F6B"/>
+                </a:solidFill>
+                <a:latin typeface="Calibri"/>
+              </a:rPr>
+              <a:t>Tablero de tareas en Jira (proyecto HELL)</a:t>
+            </a:r>
+          </a:p>
+        </p:txBody>
+      </p:sp>
+      <p:sp>
+        <p:nvSpPr>
+          <p:cNvPr id="6" name="TextBox 5"/>
+          <p:cNvSpPr txBox="1"/>
+          <p:nvPr/>
+        </p:nvSpPr>
+        <p:spPr>
+          <a:xfrm>
+            <a:off x="457200" y="1417320"/>
+            <a:ext cx="10972800" cy="365760"/>
+          </a:xfrm>
+          <a:prstGeom prst="rect">
+            <a:avLst/>
+          </a:prstGeom>
+          <a:noFill/>
+        </p:spPr>
+        <p:txBody>
+          <a:bodyPr wrap="square" lIns="0" rIns="0" tIns="0" bIns="0">
+            <a:spAutoFit/>
+          </a:bodyPr>
+          <a:lstStyle/>
+          <a:p>
+            <a:pPr algn="l"/>
+            <a:r>
+              <a:rPr sz="1300" b="0">
+                <a:solidFill>
+                  <a:srgbClr val="4A6B7A"/>
+                </a:solidFill>
+                <a:latin typeface="Calibri"/>
+              </a:rPr>
+              <a:t>15 issues creadas via API · 10 Done · 2 In Progress · 3 To Do · 53 Story Points</a:t>
+            </a:r>
+          </a:p>
+        </p:txBody>
+      </p:sp>
+      <p:sp>
+        <p:nvSpPr>
+          <p:cNvPr id="7" name="Rectangle 6"/>
+          <p:cNvSpPr/>
+          <p:nvPr/>
+        </p:nvSpPr>
+        <p:spPr>
+          <a:xfrm>
+            <a:off x="457200" y="1920240"/>
+            <a:ext cx="11247120" cy="4297680"/>
+          </a:xfrm>
+          <a:prstGeom prst="rect">
+            <a:avLst/>
+          </a:prstGeom>
+          <a:solidFill>
+            <a:srgbClr val="FFFFFF"/>
+          </a:solidFill>
+          <a:ln>
+            <a:solidFill>
+              <a:srgbClr val="0A8478"/>
+            </a:solidFill>
+          </a:ln>
+          <a:effectLst/>
+        </p:spPr>
+        <p:style>
+          <a:lnRef idx="1">
+            <a:schemeClr val="accent1"/>
+          </a:lnRef>
+          <a:fillRef idx="3">
+            <a:schemeClr val="accent1"/>
+          </a:fillRef>
+          <a:effectRef idx="2">
+            <a:schemeClr val="accent1"/>
+          </a:effectRef>
+          <a:fontRef idx="minor">
+            <a:schemeClr val="lt1"/>
+          </a:fontRef>
+        </p:style>
+        <p:txBody>
+          <a:bodyPr rtlCol="0" anchor="ctr"/>
+          <a:lstStyle/>
+          <a:p>
+            <a:pPr algn="ctr"/>
+          </a:p>
+        </p:txBody>
+      </p:sp>
+      <p:pic>
+        <p:nvPicPr>
+          <p:cNvPr id="8" name="Picture 7" descr="kanban_jira.png"/>
+          <p:cNvPicPr>
+            <a:picLocks noChangeAspect="1"/>
+          </p:cNvPicPr>
+          <p:nvPr/>
+        </p:nvPicPr>
+        <p:blipFill>
+          <a:blip r:embed="rId2"/>
+          <a:stretch>
+            <a:fillRect/>
+          </a:stretch>
+        </p:blipFill>
+        <p:spPr>
+          <a:xfrm>
+            <a:off x="548640" y="2011680"/>
+            <a:ext cx="11064240" cy="4114800"/>
+          </a:xfrm>
+          <a:prstGeom prst="rect">
+            <a:avLst/>
+          </a:prstGeom>
+        </p:spPr>
+      </p:pic>
+      <p:sp>
+        <p:nvSpPr>
+          <p:cNvPr id="9" name="Rectangle 8"/>
+          <p:cNvSpPr/>
+          <p:nvPr/>
+        </p:nvSpPr>
+        <p:spPr>
+          <a:xfrm>
+            <a:off x="457200" y="6355080"/>
+            <a:ext cx="11247120" cy="320040"/>
+          </a:xfrm>
+          <a:prstGeom prst="rect">
+            <a:avLst/>
+          </a:prstGeom>
+          <a:solidFill>
+            <a:srgbClr val="0A4F6B"/>
+          </a:solidFill>
+          <a:ln>
+            <a:noFill/>
+          </a:ln>
+          <a:effectLst/>
+        </p:spPr>
+        <p:style>
+          <a:lnRef idx="1">
+            <a:schemeClr val="accent1"/>
+          </a:lnRef>
+          <a:fillRef idx="3">
+            <a:schemeClr val="accent1"/>
+          </a:fillRef>
+          <a:effectRef idx="2">
+            <a:schemeClr val="accent1"/>
+          </a:effectRef>
+          <a:fontRef idx="minor">
+            <a:schemeClr val="lt1"/>
+          </a:fontRef>
+        </p:style>
+        <p:txBody>
+          <a:bodyPr rtlCol="0" anchor="ctr"/>
+          <a:lstStyle/>
+          <a:p>
+            <a:pPr algn="ctr"/>
+          </a:p>
+        </p:txBody>
+      </p:sp>
+      <p:sp>
+        <p:nvSpPr>
+          <p:cNvPr id="10" name="TextBox 9"/>
+          <p:cNvSpPr txBox="1"/>
+          <p:nvPr/>
+        </p:nvSpPr>
+        <p:spPr>
+          <a:xfrm>
+            <a:off x="640080" y="6391656"/>
+            <a:ext cx="10972800" cy="274320"/>
+          </a:xfrm>
+          <a:prstGeom prst="rect">
+            <a:avLst/>
+          </a:prstGeom>
+          <a:noFill/>
+        </p:spPr>
+        <p:txBody>
+          <a:bodyPr wrap="square" lIns="0" rIns="0" tIns="0" bIns="0">
+            <a:spAutoFit/>
+          </a:bodyPr>
+          <a:lstStyle/>
+          <a:p>
+            <a:pPr algn="l"/>
+            <a:r>
+              <a:rPr sz="1000" b="1">
+                <a:solidFill>
+                  <a:srgbClr val="FFFFFF"/>
+                </a:solidFill>
+                <a:latin typeface="Calibri"/>
+              </a:rPr>
+              <a:t>Cada issue tiene responsable, story points y descripción técnica · Backlog evidencia cumplimiento de la Unidad II punto 5</a:t>
+            </a:r>
+          </a:p>
+        </p:txBody>
+      </p:sp>
+      <p:sp>
+        <p:nvSpPr>
+          <p:cNvPr id="11" name="TextBox 10"/>
+          <p:cNvSpPr txBox="1"/>
+          <p:nvPr/>
+        </p:nvSpPr>
+        <p:spPr>
+          <a:xfrm>
+            <a:off x="457200" y="6583680"/>
+            <a:ext cx="7315200" cy="274320"/>
+          </a:xfrm>
+          <a:prstGeom prst="rect">
+            <a:avLst/>
+          </a:prstGeom>
+          <a:noFill/>
+        </p:spPr>
+        <p:txBody>
+          <a:bodyPr wrap="square" lIns="0" rIns="0" tIns="0" bIns="0">
+            <a:spAutoFit/>
+          </a:bodyPr>
+          <a:lstStyle/>
+          <a:p>
+            <a:pPr algn="l"/>
+            <a:r>
+              <a:rPr sz="900" b="0">
+                <a:solidFill>
+                  <a:srgbClr val="4A6B7A"/>
+                </a:solidFill>
+                <a:latin typeface="Calibri"/>
+              </a:rPr>
+              <a:t>HELIOS — Daily Scrum Semana 2 · Sprint 1 — UTP Calidad de Software · 2026</a:t>
+            </a:r>
+          </a:p>
+        </p:txBody>
+      </p:sp>
+    </p:spTree>
+  </p:cSld>
+  <p:clrMapOvr>
+    <a:masterClrMapping/>
+  </p:clrMapOvr>
+</p:sld>
+</file>
+
+<file path=ppt/slides/slide6.xml><?xml version="1.0" encoding="utf-8"?>
+<p:sld xmlns:a="http://schemas.openxmlformats.org/drawingml/2006/main" xmlns:p="http://schemas.openxmlformats.org/presentationml/2006/main" xmlns:r="http://schemas.openxmlformats.org/officeDocument/2006/relationships">
+  <p:cSld>
+    <p:bg>
+      <p:bgPr>
+        <a:solidFill>
+          <a:srgbClr val="F4F7F8"/>
+        </a:solidFill>
+        <a:effectLst/>
+      </p:bgPr>
+    </p:bg>
+    <p:spTree>
+      <p:nvGrpSpPr>
+        <p:cNvPr id="1" name=""/>
+        <p:cNvGrpSpPr/>
+        <p:nvPr/>
+      </p:nvGrpSpPr>
+      <p:grpSpPr/>
+      <p:sp>
+        <p:nvSpPr>
+          <p:cNvPr id="2" name="TextBox 1"/>
+          <p:cNvSpPr txBox="1"/>
+          <p:nvPr/>
+        </p:nvSpPr>
+        <p:spPr>
+          <a:xfrm>
+            <a:off x="457200" y="365760"/>
+            <a:ext cx="10972800" cy="274320"/>
+          </a:xfrm>
+          <a:prstGeom prst="rect">
+            <a:avLst/>
+          </a:prstGeom>
+          <a:noFill/>
+        </p:spPr>
+        <p:txBody>
+          <a:bodyPr wrap="square" lIns="0" rIns="0" tIns="0" bIns="0">
+            <a:spAutoFit/>
+          </a:bodyPr>
+          <a:lstStyle/>
+          <a:p>
+            <a:pPr algn="l"/>
+            <a:r>
+              <a:rPr sz="1100" b="1">
+                <a:solidFill>
+                  <a:srgbClr val="0A8478"/>
+                </a:solidFill>
+                <a:latin typeface="Calibri"/>
+              </a:rPr>
+              <a:t>APLICACIÓN DE LA UNIDAD II — ISTQB · TMMI · TQM</a:t>
+            </a:r>
+          </a:p>
+        </p:txBody>
+      </p:sp>
+      <p:sp>
+        <p:nvSpPr>
+          <p:cNvPr id="3" name="TextBox 2"/>
+          <p:cNvSpPr txBox="1"/>
+          <p:nvPr/>
+        </p:nvSpPr>
+        <p:spPr>
+          <a:xfrm>
+            <a:off x="11338560" y="365760"/>
+            <a:ext cx="731520" cy="274320"/>
+          </a:xfrm>
+          <a:prstGeom prst="rect">
+            <a:avLst/>
+          </a:prstGeom>
+          <a:noFill/>
+        </p:spPr>
+        <p:txBody>
+          <a:bodyPr wrap="square" lIns="0" rIns="0" tIns="0" bIns="0">
+            <a:spAutoFit/>
+          </a:bodyPr>
+          <a:lstStyle/>
+          <a:p>
+            <a:pPr algn="r"/>
+            <a:r>
+              <a:rPr sz="1100" b="1">
+                <a:solidFill>
+                  <a:srgbClr val="0A8478"/>
+                </a:solidFill>
+                <a:latin typeface="Calibri"/>
+              </a:rPr>
+              <a:t>P6</a:t>
+            </a:r>
+          </a:p>
+        </p:txBody>
+      </p:sp>
+      <p:sp>
+        <p:nvSpPr>
+          <p:cNvPr id="4" name="TextBox 3"/>
+          <p:cNvSpPr txBox="1"/>
+          <p:nvPr/>
+        </p:nvSpPr>
+        <p:spPr>
+          <a:xfrm>
+            <a:off x="11338560" y="6583680"/>
+            <a:ext cx="731520" cy="274320"/>
+          </a:xfrm>
+          <a:prstGeom prst="rect">
+            <a:avLst/>
+          </a:prstGeom>
+          <a:noFill/>
+        </p:spPr>
+        <p:txBody>
+          <a:bodyPr wrap="square" lIns="0" rIns="0" tIns="0" bIns="0">
+            <a:spAutoFit/>
+          </a:bodyPr>
+          <a:lstStyle/>
+          <a:p>
+            <a:pPr algn="r"/>
+            <a:r>
+              <a:rPr sz="900" b="0">
+                <a:solidFill>
+                  <a:srgbClr val="4A6B7A"/>
+                </a:solidFill>
+                <a:latin typeface="Calibri"/>
+              </a:rPr>
+              <a:t>6 / 6</a:t>
             </a:r>
           </a:p>
         </p:txBody>

</xml_diff>

<commit_message>
docs(metricas): documento detallado FUENTE_DE_METRICAS + KLOC reales
Para defender la presentacion ante preguntas profundas:

Nuevo: docs/FUENTE_DE_METRICAS.md (32 KB)
- Para cada metrica: que herramienta, que comando, donde la evidencia,
  como se calculo, y respuesta lista si la profesora pregunta
- Separa metricas AUTOMATIZADAS (Vitest/Locust) vs MANUALES (conteo)
- Honestidad sobre lo pendiente (SonarCloud, SUS)
- Comandos para verificar EN VIVO si pide demostracion

Nuevo: scripts/contar_kloc.py
- Conteo programatico de lineas de codigo util
- Resultado real medido hoy: 1.71 KLOC producto (frontend 1.54 + SQL 0.17)
- Anterior estimacion era 1.4 KLOC (subestimada)

Actualizado en el PPTX slide 6:
- KLOC: 1.71 (era "~1.4")
- Productividad: 0.342 KLOC/persona (era 0.28)
- Agregada tasa defectos: 1.75 bugs/KLOC (3 bugs / 1.71)

Actualizado generadores:
- generar_docs_finales.py: agrega doc 04 a PDFs y DOCX
- generar_pdf_docs.py: PDF combinado ahora incluye 4 secciones (90 KB)
</commit_message>
<xml_diff>
--- a/dailys/Daily_S2_Sprint1_HELIOS.pptx
+++ b/dailys/Daily_S2_Sprint1_HELIOS.pptx
@@ -11579,7 +11579,7 @@
                 </a:solidFill>
                 <a:latin typeface="Calibri"/>
               </a:rPr>
-              <a:t>KLOC del Sprint</a:t>
+              <a:t>KLOC del Sprint (producto)</a:t>
             </a:r>
           </a:p>
         </p:txBody>
@@ -11614,7 +11614,7 @@
                 </a:solidFill>
                 <a:latin typeface="Calibri"/>
               </a:rPr>
-              <a:t>≈ 1.4 KLOC</a:t>
+              <a:t>1.71 KLOC medidas</a:t>
             </a:r>
           </a:p>
         </p:txBody>
@@ -11649,7 +11649,7 @@
                 </a:solidFill>
                 <a:latin typeface="Calibri"/>
               </a:rPr>
-              <a:t>cloc / SonarCloud</a:t>
+              <a:t>Script Python conteo</a:t>
             </a:r>
           </a:p>
         </p:txBody>
@@ -11833,7 +11833,7 @@
                 </a:solidFill>
                 <a:latin typeface="Calibri"/>
               </a:rPr>
-              <a:t>0.28 KLOC/persona</a:t>
+              <a:t>0.342 KLOC/persona</a:t>
             </a:r>
           </a:p>
         </p:txBody>
@@ -11868,7 +11868,7 @@
                 </a:solidFill>
                 <a:latin typeface="Calibri"/>
               </a:rPr>
-              <a:t>Cálculo manual</a:t>
+              <a:t>1.71/5 personas</a:t>
             </a:r>
           </a:p>
         </p:txBody>
@@ -11982,7 +11982,7 @@
                 </a:solidFill>
                 <a:latin typeface="Calibri"/>
               </a:rPr>
-              <a:t>Proceso</a:t>
+              <a:t>Clásicas (Pressman)</a:t>
             </a:r>
           </a:p>
         </p:txBody>
@@ -12017,7 +12017,7 @@
                 </a:solidFill>
                 <a:latin typeface="Calibri"/>
               </a:rPr>
-              <a:t>Ciclo Goal→Metric→Acción</a:t>
+              <a:t>Tasa de defectos</a:t>
             </a:r>
           </a:p>
         </p:txBody>
@@ -12052,7 +12052,7 @@
                 </a:solidFill>
                 <a:latin typeface="Calibri"/>
               </a:rPr>
-              <a:t>Documentado en daily MD</a:t>
+              <a:t>1.75 bugs/KLOC</a:t>
             </a:r>
           </a:p>
         </p:txBody>
@@ -12087,7 +12087,7 @@
                 </a:solidFill>
                 <a:latin typeface="Calibri"/>
               </a:rPr>
-              <a:t>Daily Scrum semanal</a:t>
+              <a:t>3 bugs / 1.71 KLOC</a:t>
             </a:r>
           </a:p>
         </p:txBody>
@@ -12122,6 +12122,225 @@
                 </a:solidFill>
                 <a:latin typeface="Calibri"/>
               </a:rPr>
+              <a:t>Pressman</a:t>
+            </a:r>
+          </a:p>
+        </p:txBody>
+      </p:sp>
+      <p:sp>
+        <p:nvSpPr>
+          <p:cNvPr id="103" name="Rectangle 102"/>
+          <p:cNvSpPr/>
+          <p:nvPr/>
+        </p:nvSpPr>
+        <p:spPr>
+          <a:xfrm>
+            <a:off x="457200" y="7086600"/>
+            <a:ext cx="11247120" cy="320040"/>
+          </a:xfrm>
+          <a:prstGeom prst="rect">
+            <a:avLst/>
+          </a:prstGeom>
+          <a:solidFill>
+            <a:srgbClr val="ECF2F4"/>
+          </a:solidFill>
+          <a:ln>
+            <a:noFill/>
+          </a:ln>
+          <a:effectLst/>
+        </p:spPr>
+        <p:style>
+          <a:lnRef idx="1">
+            <a:schemeClr val="accent1"/>
+          </a:lnRef>
+          <a:fillRef idx="3">
+            <a:schemeClr val="accent1"/>
+          </a:fillRef>
+          <a:effectRef idx="2">
+            <a:schemeClr val="accent1"/>
+          </a:effectRef>
+          <a:fontRef idx="minor">
+            <a:schemeClr val="lt1"/>
+          </a:fontRef>
+        </p:style>
+        <p:txBody>
+          <a:bodyPr rtlCol="0" anchor="ctr"/>
+          <a:lstStyle/>
+          <a:p>
+            <a:pPr algn="ctr"/>
+          </a:p>
+        </p:txBody>
+      </p:sp>
+      <p:sp>
+        <p:nvSpPr>
+          <p:cNvPr id="104" name="TextBox 103"/>
+          <p:cNvSpPr txBox="1"/>
+          <p:nvPr/>
+        </p:nvSpPr>
+        <p:spPr>
+          <a:xfrm>
+            <a:off x="548640" y="7141464"/>
+            <a:ext cx="1737360" cy="274320"/>
+          </a:xfrm>
+          <a:prstGeom prst="rect">
+            <a:avLst/>
+          </a:prstGeom>
+          <a:noFill/>
+        </p:spPr>
+        <p:txBody>
+          <a:bodyPr wrap="square" lIns="0" rIns="0" tIns="0" bIns="0">
+            <a:spAutoFit/>
+          </a:bodyPr>
+          <a:lstStyle/>
+          <a:p>
+            <a:pPr algn="l"/>
+            <a:r>
+              <a:rPr sz="900" b="1">
+                <a:solidFill>
+                  <a:srgbClr val="0A8478"/>
+                </a:solidFill>
+                <a:latin typeface="Calibri"/>
+              </a:rPr>
+              <a:t>Proceso</a:t>
+            </a:r>
+          </a:p>
+        </p:txBody>
+      </p:sp>
+      <p:sp>
+        <p:nvSpPr>
+          <p:cNvPr id="105" name="TextBox 104"/>
+          <p:cNvSpPr txBox="1"/>
+          <p:nvPr/>
+        </p:nvSpPr>
+        <p:spPr>
+          <a:xfrm>
+            <a:off x="2377440" y="7141464"/>
+            <a:ext cx="3108960" cy="274320"/>
+          </a:xfrm>
+          <a:prstGeom prst="rect">
+            <a:avLst/>
+          </a:prstGeom>
+          <a:noFill/>
+        </p:spPr>
+        <p:txBody>
+          <a:bodyPr wrap="square" lIns="0" rIns="0" tIns="0" bIns="0">
+            <a:spAutoFit/>
+          </a:bodyPr>
+          <a:lstStyle/>
+          <a:p>
+            <a:pPr algn="l"/>
+            <a:r>
+              <a:rPr sz="900" b="0">
+                <a:solidFill>
+                  <a:srgbClr val="0F2A36"/>
+                </a:solidFill>
+                <a:latin typeface="Calibri"/>
+              </a:rPr>
+              <a:t>Ciclo Goal→Metric→Acción</a:t>
+            </a:r>
+          </a:p>
+        </p:txBody>
+      </p:sp>
+      <p:sp>
+        <p:nvSpPr>
+          <p:cNvPr id="106" name="TextBox 105"/>
+          <p:cNvSpPr txBox="1"/>
+          <p:nvPr/>
+        </p:nvSpPr>
+        <p:spPr>
+          <a:xfrm>
+            <a:off x="5577840" y="7141464"/>
+            <a:ext cx="2468880" cy="274320"/>
+          </a:xfrm>
+          <a:prstGeom prst="rect">
+            <a:avLst/>
+          </a:prstGeom>
+          <a:noFill/>
+        </p:spPr>
+        <p:txBody>
+          <a:bodyPr wrap="square" lIns="0" rIns="0" tIns="0" bIns="0">
+            <a:spAutoFit/>
+          </a:bodyPr>
+          <a:lstStyle/>
+          <a:p>
+            <a:pPr algn="l"/>
+            <a:r>
+              <a:rPr sz="900" b="0">
+                <a:solidFill>
+                  <a:srgbClr val="0F2A36"/>
+                </a:solidFill>
+                <a:latin typeface="Calibri"/>
+              </a:rPr>
+              <a:t>Documentado en daily MD</a:t>
+            </a:r>
+          </a:p>
+        </p:txBody>
+      </p:sp>
+      <p:sp>
+        <p:nvSpPr>
+          <p:cNvPr id="107" name="TextBox 106"/>
+          <p:cNvSpPr txBox="1"/>
+          <p:nvPr/>
+        </p:nvSpPr>
+        <p:spPr>
+          <a:xfrm>
+            <a:off x="8138160" y="7141464"/>
+            <a:ext cx="1920240" cy="274320"/>
+          </a:xfrm>
+          <a:prstGeom prst="rect">
+            <a:avLst/>
+          </a:prstGeom>
+          <a:noFill/>
+        </p:spPr>
+        <p:txBody>
+          <a:bodyPr wrap="square" lIns="0" rIns="0" tIns="0" bIns="0">
+            <a:spAutoFit/>
+          </a:bodyPr>
+          <a:lstStyle/>
+          <a:p>
+            <a:pPr algn="l"/>
+            <a:r>
+              <a:rPr sz="900" b="0">
+                <a:solidFill>
+                  <a:srgbClr val="0F2A36"/>
+                </a:solidFill>
+                <a:latin typeface="Calibri"/>
+              </a:rPr>
+              <a:t>Daily Scrum semanal</a:t>
+            </a:r>
+          </a:p>
+        </p:txBody>
+      </p:sp>
+      <p:sp>
+        <p:nvSpPr>
+          <p:cNvPr id="108" name="TextBox 107"/>
+          <p:cNvSpPr txBox="1"/>
+          <p:nvPr/>
+        </p:nvSpPr>
+        <p:spPr>
+          <a:xfrm>
+            <a:off x="10149840" y="7141464"/>
+            <a:ext cx="1554480" cy="274320"/>
+          </a:xfrm>
+          <a:prstGeom prst="rect">
+            <a:avLst/>
+          </a:prstGeom>
+          <a:noFill/>
+        </p:spPr>
+        <p:txBody>
+          <a:bodyPr wrap="square" lIns="0" rIns="0" tIns="0" bIns="0">
+            <a:spAutoFit/>
+          </a:bodyPr>
+          <a:lstStyle/>
+          <a:p>
+            <a:pPr algn="l"/>
+            <a:r>
+              <a:rPr sz="900" b="1">
+                <a:solidFill>
+                  <a:srgbClr val="0A8478"/>
+                </a:solidFill>
+                <a:latin typeface="Calibri"/>
+              </a:rPr>
               <a:t>TQM</a:t>
             </a:r>
           </a:p>
@@ -12129,7 +12348,7 @@
       </p:sp>
       <p:sp>
         <p:nvSpPr>
-          <p:cNvPr id="103" name="Rectangle 102"/>
+          <p:cNvPr id="109" name="Rectangle 108"/>
           <p:cNvSpPr/>
           <p:nvPr/>
         </p:nvSpPr>
@@ -12173,7 +12392,7 @@
       </p:sp>
       <p:sp>
         <p:nvSpPr>
-          <p:cNvPr id="104" name="TextBox 103"/>
+          <p:cNvPr id="110" name="TextBox 109"/>
           <p:cNvSpPr txBox="1"/>
           <p:nvPr/>
         </p:nvSpPr>

</xml_diff>